<commit_message>
Landing and guide updated for YouTube publishing; cross-linked
- Landing: Outputs feature card now covers one-click YouTube publishing
  (private by default); GitHub repo linked in the nav and footer
- User guide: narration introduces the landing page as the front door
  (guide video + example productions + Open the Studio) and walks the
  YouTube card on the outputs station; outputs screenshot retaken
  showing the publish form. Updated via in-place source replacement and
  two targeted script revisions on the same project, then re-rendered
  with animations; demo snapshot refreshed to match

Co-Authored-By: Claude Fable 5 <noreply@anthropic.com>
</commit_message>
<xml_diff>
--- a/demo/data/14968b573e78/slides.pptx
+++ b/demo/data/14968b573e78/slides.pptx
@@ -20,6 +20,7 @@
     <p:sldId id="268" r:id="rId20"/>
     <p:sldId id="269" r:id="rId21"/>
     <p:sldId id="270" r:id="rId22"/>
+    <p:sldId id="271" r:id="rId23"/>
   </p:sldIdLst>
   <p:sldSz cx="12191695" cy="6858000" type="screen4x3"/>
   <p:notesSz cx="6858000" cy="9144000"/>
@@ -592,7 +593,7 @@
           <a:lstStyle/>
           <a:p>
             <a:r>
-              <a:t>Slides revise exactly like the script — same kind of box at the bottom, same plain English: "Make every title a question." "Merge slides three and four." And if your company has a visual identity, click that Templates button back in the top-left corner: it opens a page where you upload a PowerPoint template, a style-guide document, or even a screenshot of slides you like. The studio reads the colors and fonts out of whatever you give it and applies them to everything it renders. Save the files once as a named set, and every future project can use it from a simple dropdown menu.</a:t>
+              <a:t>On to station two: the slides. Click Slides and the deck appears as a grid of small cards, one card per slide, like a storyboard. Each card shows the slide's number, the moment in the audio when it will appear, its title and bullet points, and — when the slide carries a picture or a chart — a small preview of it. The pictures aren't decoration pulled from a stock library: the studio lifts real images out of your source document, and it draws its own charts, timelines, and diagrams whenever the material contains data worth showing. Scroll to the bottom of this page and you'll find the Asset Inventory — a gallery of every image and figure with a note saying exactly which slide uses each one, so nothing in your production is a mystery.</a:t>
             </a:r>
           </a:p>
         </p:txBody>
@@ -662,7 +663,7 @@
           <a:lstStyle/>
           <a:p>
             <a:r>
-              <a:t>Now for station three: the voice — the part that sounds hardest and isn't. Each slide card carries a tiny play symbol in its top corner. Click it and the screen dims: your slide appears large in the middle, and a slim control bar sits beneath it with pause, previous and next arrows, a progress line, and an auto-advance switch. What you hear is precisely the stretch of narration that belongs to that slide — not the whole episode. That's what's on screen now: one slide, under review, with its own segment of voice. Step through your whole production this way; it's how you catch the slide that arrives one beat too late or the sentence that needs more air.</a:t>
+              <a:t>Slides revise exactly like the script — same kind of box at the bottom, same plain English: "Make every title a question." "Merge slides three and four." And if your company has a visual identity, click that Templates button back in the top-left corner: it opens a page where you upload a PowerPoint template, a style-guide document, or even a screenshot of slides you like. The studio reads the colors and fonts out of whatever you give it and applies them to everything it renders. Save the files once as a named set, and every future project can use it from a simple dropdown menu.</a:t>
             </a:r>
           </a:p>
         </p:txBody>
@@ -732,7 +733,7 @@
           <a:lstStyle/>
           <a:p>
             <a:r>
-              <a:t>When something sounds off, go to the Voice page — the third light — and give instructions that mention line numbers from the script: "Line 4, slow down ten percent and pause after the question." "Pronounce Nguyen as win, everywhere." The written transcript keeps the correct spelling; only the pronunciation changes, and the audio re-records itself within a minute or two. And if a slide appears at the wrong moment, every card has a small offset box: type minus two to bring it in two seconds earlier, press Apply Timing, and the visuals re-sync without re-recording anything.</a:t>
+              <a:t>Now for station three: the voice — the part that sounds hardest and isn't. Each slide card carries a tiny play symbol in its top corner. Click it and the screen dims: your slide appears large in the middle, and a slim control bar sits beneath it with pause, previous and next arrows, a progress line, and an auto-advance switch. What you hear is precisely the stretch of narration that belongs to that slide — not the whole episode. That's what's on screen now: one slide, under review, with its own segment of voice. Step through your whole production this way; it's how you catch the slide that arrives one beat too late or the sentence that needs more air.</a:t>
             </a:r>
           </a:p>
         </p:txBody>
@@ -802,7 +803,7 @@
           <a:lstStyle/>
           <a:p>
             <a:r>
-              <a:t>And finally, station four: the outputs — the packaging department. At the top sits an amber Render Production button with menus beside it for slides, captions and animations — press it and the studio assembles everything from your current script, slides and voice direction. Below, each finished file gets its own card: the Audio card holds the episode with a play bar and a download link; the Transcript card shows the full text with a timestamp on every line; the Web Slideshow card opens the synced presentation — a single file, sound included, that you can send to anyone; the Video card previews the movie file; and the PowerPoint card downloads a deck that carries the narration as speaker notes under every slide, so you can present it yourself and read what the voice would have said.</a:t>
+              <a:t>When something sounds off, go to the Voice page — the third light — and give instructions that mention line numbers from the script: "Line 4, slow down ten percent and pause after the question." "Pronounce Nguyen as win, everywhere." The written transcript keeps the correct spelling; only the pronunciation changes, and the audio re-records itself within a minute or two. And if a slide appears at the wrong moment, every card has a small offset box: type minus two to bring it in two seconds earlier, press Apply Timing, and the visuals re-sync without re-recording anything.</a:t>
             </a:r>
           </a:p>
         </p:txBody>
@@ -872,7 +873,7 @@
           <a:lstStyle/>
           <a:p>
             <a:r>
-              <a:t>One honest note about money. The studio's writing and design run on a paid artificial-intelligence service. Next to each project's title you'll find a small capsule reading something like "approximately forty cents model spend" — that's the project's real running cost, usually well under a dollar for a full production. The studio also makes repeat revisions cheap: when you iterate several times within a few minutes, the repeated material is billed at roughly a tenth of normal price. So work the way good producers work anyway — in focused bursts.</a:t>
+              <a:t>And finally, station four: the outputs — the packaging department. At the top sits an amber Render Production button with menus beside it for slides, captions and animations — press it and the studio assembles everything from your current script, slides and voice direction. Below, each finished file gets its own card: the Audio card holds the episode with a play bar and a download link; the Transcript card shows the full text with a timestamp on every line; the Web Slideshow card opens the synced presentation — a single file, sound included, that you can send to anyone; the Video card previews the movie file; and the PowerPoint card downloads a deck that carries the narration as speaker notes under every slide, so you can present it yourself and read what the voice would have said. There's one more card on this page: YouTube. Once you've connected your channel — a one-time, five-minute setup the card walks you through — publishing your video is a single button. It uploads as private, so you review it on YouTube before anyone else can see it, and the link is saved on your project.</a:t>
             </a:r>
           </a:p>
         </p:txBody>
@@ -942,6 +943,76 @@
           <a:lstStyle/>
           <a:p>
             <a:r>
+              <a:t>One honest note about money. The studio's writing and design run on a paid artificial-intelligence service. Next to each project's title you'll find a small capsule reading something like "approximately forty cents model spend" — that's the project's real running cost, usually well under a dollar for a full production. The studio also makes repeat revisions cheap: when you iterate several times within a few minutes, the repeated material is billed at roughly a tenth of normal price. So work the way good producers work anyway — in focused bursts.</a:t>
+            </a:r>
+          </a:p>
+        </p:txBody>
+      </p:sp>
+      <p:sp>
+        <p:nvSpPr>
+          <p:cNvPr id="4" name="Slide Number Placeholder 3"/>
+          <p:cNvSpPr>
+            <a:spLocks noGrp="1"/>
+          </p:cNvSpPr>
+          <p:nvPr>
+            <p:ph type="sldNum" idx="5" sz="quarter"/>
+          </p:nvPr>
+        </p:nvSpPr>
+        <p:spPr/>
+      </p:sp>
+    </p:spTree>
+  </p:cSld>
+  <p:clrMapOvr>
+    <a:masterClrMapping/>
+  </p:clrMapOvr>
+</p:notes>
+</file>
+
+<file path=ppt/notesSlides/notesSlide16.xml><?xml version="1.0" encoding="utf-8"?>
+<p:notes xmlns:a="http://schemas.openxmlformats.org/drawingml/2006/main" xmlns:p="http://schemas.openxmlformats.org/presentationml/2006/main" xmlns:r="http://schemas.openxmlformats.org/officeDocument/2006/relationships">
+  <p:cSld>
+    <p:spTree>
+      <p:nvGrpSpPr>
+        <p:cNvPr id="1" name=""/>
+        <p:cNvGrpSpPr/>
+        <p:nvPr/>
+      </p:nvGrpSpPr>
+      <p:grpSpPr>
+        <a:xfrm>
+          <a:off x="0" y="0"/>
+          <a:ext cx="0" cy="0"/>
+          <a:chOff x="0" y="0"/>
+          <a:chExt cx="0" cy="0"/>
+        </a:xfrm>
+      </p:grpSpPr>
+      <p:sp>
+        <p:nvSpPr>
+          <p:cNvPr id="2" name="Slide Image Placeholder 1"/>
+          <p:cNvSpPr>
+            <a:spLocks noGrp="1"/>
+          </p:cNvSpPr>
+          <p:nvPr>
+            <p:ph type="sldImg" idx="2"/>
+          </p:nvPr>
+        </p:nvSpPr>
+        <p:spPr/>
+      </p:sp>
+      <p:sp>
+        <p:nvSpPr>
+          <p:cNvPr id="3" name="Notes Placeholder 2"/>
+          <p:cNvSpPr>
+            <a:spLocks noGrp="1"/>
+          </p:cNvSpPr>
+          <p:nvPr>
+            <p:ph type="body" idx="3" sz="quarter"/>
+          </p:nvPr>
+        </p:nvSpPr>
+        <p:spPr/>
+        <p:txBody>
+          <a:bodyPr/>
+          <a:lstStyle/>
+          <a:p>
+            <a:r>
               <a:t>Let's bring it all together — the whole method in one breath. Start a project with a source, a mode, and an audience, and run it only until the script. Read the script and revise it in plain sentences until it says what you mean. Shape the slides the same way, with your template if you have one. Render. Review slide by slide with the little play buttons, fix pronunciation and pacing by line number, nudge timings. Collect five finished files from the Outputs page. Notice what never happened: no audio editing, no slide designing, no video software. The production skills are built into the studio — the only skill you brought was knowing what you wanted to say, and to whom. Everything you've just watched and heard, including these very slides and this voice, was produced by the studio this guide describes. Your turn: one pasted link, and you're a producer.</a:t>
             </a:r>
           </a:p>
@@ -1082,7 +1153,7 @@
           <a:lstStyle/>
           <a:p>
             <a:r>
-              <a:t>So let's take your first look at the studio. When you open it in your browser, you're looking at a dark page split into two areas. Down the left side runs a narrow column — that's the library, the list of everything you've ever produced, with a search box above it. Nothing in the library disappears when you close the app. At the top of that column sit two buttons: an amber one labeled New Generation — amber is the studio's signature orange-gold color, and that button is where every project begins — and a plain one labeled Templates, which we'll come back to. The large area to the right is your workspace, and it opens on a form titled "From source to sound." That form is what you're seeing on the slide right now.</a:t>
+              <a:t>So let's take your first look at the studio. The studio's web address, fluentagents.com, greets you with its front door: a landing page where this very guide plays as a video, with real example productions to explore beneath it. Press the amber Open the Studio button there and you're in the workbench — which is where our tour begins.</a:t>
             </a:r>
           </a:p>
         </p:txBody>
@@ -1152,7 +1223,7 @@
           <a:lstStyle/>
           <a:p>
             <a:r>
-              <a:t>Now let's fill in the form, top to bottom. It reads in three boxes. The first box is labeled Source. It has two small round buttons — URL and PDF upload — and a wide text field. Paste a web address into the field, or click PDF upload and choose a file. Easier still: drag a PDF from your computer anywhere onto that box and it attaches itself, showing the file's name in amber so you know it took.</a:t>
+              <a:t>Inside the studio, you're looking at a dark page split into two areas. Down the left side runs a narrow column — that's the library, the list of everything you've ever produced, with a search box above it. Nothing in the library disappears when you close the app. At the top of that column sit two buttons: an amber one labeled New Generation — amber is the studio's signature orange-gold color, and that button is where every project begins — and a plain one labeled Templates, which we'll come back to. The large area to the right is your workspace, and it opens on a form titled "From source to sound." That form is what you're seeing on the slide right now.</a:t>
             </a:r>
           </a:p>
         </p:txBody>
@@ -1222,7 +1293,7 @@
           <a:lstStyle/>
           <a:p>
             <a:r>
-              <a:t>The second box, Production, is where you make the three decisions that matter. The Mode menu decides the kind of listening experience: Podcast turns your source into a lively conversation between two hosts; Summary gives you one narrator delivering the short version in a few minutes; Readout is the whole document read aloud faithfully, like an audiobook. The Run Until menu decides how far the studio goes before pausing for you: choose Script Draft and it stops after writing the words — the cheap, safe place to start; choose Full Production and it goes all the way. And the Audience field is a plain-text box where you describe who will listen — type "complete beginners" or "busy executives who want numbers," and the writing, the examples, and the level of explanation all shift to fit those people. Below these sit optional personality fields — describe a host as "an enthusiastic teacher who loves analogies" and that is exactly who you'll hear — and voice pickers, which you can safely leave empty.</a:t>
+              <a:t>Now let's fill in the form, top to bottom. It reads in three boxes. The first box is labeled Source. It has two small round buttons — URL and PDF upload — and a wide text field. Paste a web address into the field, or click PDF upload and choose a file. Easier still: drag a PDF from your computer anywhere onto that box and it attaches itself, showing the file's name in amber so you know it took.</a:t>
             </a:r>
           </a:p>
         </p:txBody>
@@ -1292,7 +1363,7 @@
           <a:lstStyle/>
           <a:p>
             <a:r>
-              <a:t>The third box, Slides and Captions, chooses your outputs. Slides picks the formats: web slideshow, video, PowerPoint, or a combination. Captions are the spoken words shown as text on screen — pick Burned to print them permanently into the video, or Toggle so each viewer can turn them on and off. Animations, when switched on, makes slide content glide in element by element instead of appearing all at once — you're seeing that effect on these very slides. Then the amber Start Generation button at the bottom sets it all in motion.</a:t>
+              <a:t>The second box, Production, is where you make the three decisions that matter. The Mode menu decides the kind of listening experience: Podcast turns your source into a lively conversation between two hosts; Summary gives you one narrator delivering the short version in a few minutes; Readout is the whole document read aloud faithfully, like an audiobook. The Run Until menu decides how far the studio goes before pausing for you: choose Script Draft and it stops after writing the words — the cheap, safe place to start; choose Full Production and it goes all the way. And the Audience field is a plain-text box where you describe who will listen — type "complete beginners" or "busy executives who want numbers," and the writing, the examples, and the level of explanation all shift to fit those people. Below these sit optional personality fields — describe a host as "an enthusiastic teacher who loves analogies" and that is exactly who you'll hear — and voice pickers, which you can safely leave empty.</a:t>
             </a:r>
           </a:p>
         </p:txBody>
@@ -1362,7 +1433,7 @@
           <a:lstStyle/>
           <a:p>
             <a:r>
-              <a:t>Now let's talk about the project page and the four lights. The moment you start, the studio opens your project's own page. The project's title sits large at the top, with a small status capsule on the right that says whether it's working or done. And just below the title runs the most important thing on the page: a horizontal strip with four dots connected by a line, labeled Script, Slides, Voice, and Outputs. Think of it as four stations on an assembly line — first the words get written, then the visuals get designed, then the voice gets recorded, then everything gets packaged. A solid amber dot means that station is finished; a pulsing dot means it's working right now. Each label is clickable and takes you to that station's page. The studio's whole philosophy lives in this strip: you can stop at any station, say what you'd like changed, and everything after it updates automatically.</a:t>
+              <a:t>The third box, Slides and Captions, chooses your outputs. Slides picks the formats: web slideshow, video, PowerPoint, or a combination. Captions are the spoken words shown as text on screen — pick Burned to print them permanently into the video, or Toggle so each viewer can turn them on and off. Animations, when switched on, makes slide content glide in element by element instead of appearing all at once — you're seeing that effect on these very slides. Then the amber Start Generation button at the bottom sets it all in motion.</a:t>
             </a:r>
           </a:p>
         </p:txBody>
@@ -1432,7 +1503,7 @@
           <a:lstStyle/>
           <a:p>
             <a:r>
-              <a:t>Let's visit station one: the script. Click Script — the first light — and you see the transcript: every sentence the voice will speak, laid out as a numbered list, each line carrying a small letter badge showing which speaker says it. What's on the slide now is a real script page. Read it the way a director reads a draft. When you want changes, look at the bottom of the page: there's a large text box labeled Revision Instructions with an amber Revise Script button beside it. Type what you want in plain words — "Open with a question instead of an announcement," "Cut the part about pricing," "Make the second host funnier" — and the studio rewrites exactly what you asked for, leaving every other line word-for-word untouched. A revision takes about a minute, and this is the single most important habit to learn: polish the words while they're cheap, before any audio or video exists.</a:t>
+              <a:t>Now let's talk about the project page and the four lights. The moment you start, the studio opens your project's own page. The project's title sits large at the top, with a small status capsule on the right that says whether it's working or done. And just below the title runs the most important thing on the page: a horizontal strip with four dots connected by a line, labeled Script, Slides, Voice, and Outputs. Think of it as four stations on an assembly line — first the words get written, then the visuals get designed, then the voice gets recorded, then everything gets packaged. A solid amber dot means that station is finished; a pulsing dot means it's working right now. Each label is clickable and takes you to that station's page. The studio's whole philosophy lives in this strip: you can stop at any station, say what you'd like changed, and everything after it updates automatically.</a:t>
             </a:r>
           </a:p>
         </p:txBody>
@@ -1502,7 +1573,7 @@
           <a:lstStyle/>
           <a:p>
             <a:r>
-              <a:t>On to station two: the slides. Click Slides and the deck appears as a grid of small cards, one card per slide, like a storyboard. Each card shows the slide's number, the moment in the audio when it will appear, its title and bullet points, and — when the slide carries a picture or a chart — a small preview of it. The pictures aren't decoration pulled from a stock library: the studio lifts real images out of your source document, and it draws its own charts, timelines, and diagrams whenever the material contains data worth showing. Scroll to the bottom of this page and you'll find the Asset Inventory — a gallery of every image and figure with a note saying exactly which slide uses each one, so nothing in your production is a mystery.</a:t>
+              <a:t>Let's visit station one: the script. Click Script — the first light — and you see the transcript: every sentence the voice will speak, laid out as a numbered list, each line carrying a small letter badge showing which speaker says it. What's on the slide now is a real script page. Read it the way a director reads a draft. When you want changes, look at the bottom of the page: there's a large text box labeled Revision Instructions with an amber Revise Script button beside it. Type what you want in plain words — "Open with a question instead of an announcement," "Cut the part about pricing," "Make the second host funnier" — and the studio rewrites exactly what you asked for, leaving every other line word-for-word untouched. A revision takes about a minute, and this is the single most important habit to learn: polish the words while they're cheap, before any audio or video exists.</a:t>
             </a:r>
           </a:p>
         </p:txBody>
@@ -4663,7 +4734,7 @@
               </a:defRPr>
             </a:pPr>
             <a:r>
-              <a:t>1 / 15</a:t>
+              <a:t>1 / 16</a:t>
             </a:r>
           </a:p>
         </p:txBody>
@@ -4769,7 +4840,7 @@
               </a:defRPr>
             </a:pPr>
             <a:r>
-              <a:t>Templates — your brand</a:t>
+              <a:t>Station 2 — the slides</a:t>
             </a:r>
           </a:p>
         </p:txBody>
@@ -4808,7 +4879,7 @@
               </a:defRPr>
             </a:pPr>
             <a:r>
-              <a:t>•  Upload a theme, style guide, or screenshot</a:t>
+              <a:t>•  A storyboard grid of cards</a:t>
             </a:r>
           </a:p>
           <a:p>
@@ -4824,7 +4895,7 @@
               </a:defRPr>
             </a:pPr>
             <a:r>
-              <a:t>•  Studio reads your colors and fonts</a:t>
+              <a:t>•  Real images pulled from your source</a:t>
             </a:r>
           </a:p>
           <a:p>
@@ -4840,14 +4911,30 @@
               </a:defRPr>
             </a:pPr>
             <a:r>
-              <a:t>•  Save once, reuse from a dropdown</a:t>
+              <a:t>•  Charts and diagrams drawn from data</a:t>
+            </a:r>
+          </a:p>
+          <a:p>
+            <a:pPr>
+              <a:spcAft>
+                <a:spcPts val="1200"/>
+              </a:spcAft>
+              <a:defRPr sz="1800">
+                <a:solidFill>
+                  <a:srgbClr val="F2F0EB"/>
+                </a:solidFill>
+                <a:latin typeface="Helvetica Neue"/>
+              </a:defRPr>
+            </a:pPr>
+            <a:r>
+              <a:t>•  Asset Inventory maps every image</a:t>
             </a:r>
           </a:p>
         </p:txBody>
       </p:sp>
       <p:pic>
         <p:nvPicPr>
-          <p:cNvPr id="5" name="Picture 4" descr="img_04.jpg"/>
+          <p:cNvPr id="5" name="Picture 4" descr="img_03.jpg"/>
           <p:cNvPicPr>
             <a:picLocks noChangeAspect="1"/>
           </p:cNvPicPr>
@@ -4900,7 +4987,7 @@
               </a:defRPr>
             </a:pPr>
             <a:r>
-              <a:t>10 / 15</a:t>
+              <a:t>10 / 16</a:t>
             </a:r>
           </a:p>
         </p:txBody>
@@ -5006,7 +5093,7 @@
               </a:defRPr>
             </a:pPr>
             <a:r>
-              <a:t>Station 3 — Voice review</a:t>
+              <a:t>Templates: your brand identity</a:t>
             </a:r>
           </a:p>
         </p:txBody>
@@ -5045,7 +5132,7 @@
               </a:defRPr>
             </a:pPr>
             <a:r>
-              <a:t>•  Play button dims screen, shows slide large</a:t>
+              <a:t>•  Upload a theme, style guide, or screenshot</a:t>
             </a:r>
           </a:p>
           <a:p>
@@ -5061,14 +5148,30 @@
               </a:defRPr>
             </a:pPr>
             <a:r>
-              <a:t>•  You hear only that slide's narration</a:t>
+              <a:t>•  Studio reads colors and fonts</a:t>
+            </a:r>
+          </a:p>
+          <a:p>
+            <a:pPr>
+              <a:spcAft>
+                <a:spcPts val="1200"/>
+              </a:spcAft>
+              <a:defRPr sz="1800">
+                <a:solidFill>
+                  <a:srgbClr val="F2F0EB"/>
+                </a:solidFill>
+                <a:latin typeface="Helvetica Neue"/>
+              </a:defRPr>
+            </a:pPr>
+            <a:r>
+              <a:t>•  Save once, reuse from a dropdown</a:t>
             </a:r>
           </a:p>
         </p:txBody>
       </p:sp>
       <p:pic>
         <p:nvPicPr>
-          <p:cNvPr id="5" name="Picture 4" descr="img_05.jpg"/>
+          <p:cNvPr id="5" name="Picture 4" descr="img_04.jpg"/>
           <p:cNvPicPr>
             <a:picLocks noChangeAspect="1"/>
           </p:cNvPicPr>
@@ -5121,7 +5224,7 @@
               </a:defRPr>
             </a:pPr>
             <a:r>
-              <a:t>11 / 15</a:t>
+              <a:t>11 / 16</a:t>
             </a:r>
           </a:p>
         </p:txBody>
@@ -5227,7 +5330,7 @@
               </a:defRPr>
             </a:pPr>
             <a:r>
-              <a:t>Fixing what's off</a:t>
+              <a:t>Station 3 — the voice</a:t>
             </a:r>
           </a:p>
         </p:txBody>
@@ -5266,14 +5369,62 @@
               </a:defRPr>
             </a:pPr>
             <a:r>
-              <a:t>•  Direct by line number; audio re-records in ~1 min</a:t>
+              <a:t>•  Click a card's play symbol</a:t>
+            </a:r>
+          </a:p>
+          <a:p>
+            <a:pPr>
+              <a:spcAft>
+                <a:spcPts val="1200"/>
+              </a:spcAft>
+              <a:defRPr sz="1800">
+                <a:solidFill>
+                  <a:srgbClr val="F2F0EB"/>
+                </a:solidFill>
+                <a:latin typeface="Helvetica Neue"/>
+              </a:defRPr>
+            </a:pPr>
+            <a:r>
+              <a:t>•  Screen dims, one slide plays big</a:t>
+            </a:r>
+          </a:p>
+          <a:p>
+            <a:pPr>
+              <a:spcAft>
+                <a:spcPts val="1200"/>
+              </a:spcAft>
+              <a:defRPr sz="1800">
+                <a:solidFill>
+                  <a:srgbClr val="F2F0EB"/>
+                </a:solidFill>
+                <a:latin typeface="Helvetica Neue"/>
+              </a:defRPr>
+            </a:pPr>
+            <a:r>
+              <a:t>•  You hear only that slide's narration</a:t>
+            </a:r>
+          </a:p>
+          <a:p>
+            <a:pPr>
+              <a:spcAft>
+                <a:spcPts val="1200"/>
+              </a:spcAft>
+              <a:defRPr sz="1800">
+                <a:solidFill>
+                  <a:srgbClr val="F2F0EB"/>
+                </a:solidFill>
+                <a:latin typeface="Helvetica Neue"/>
+              </a:defRPr>
+            </a:pPr>
+            <a:r>
+              <a:t>•  Step through to catch timing slips</a:t>
             </a:r>
           </a:p>
         </p:txBody>
       </p:sp>
       <p:pic>
         <p:nvPicPr>
-          <p:cNvPr id="5" name="Picture 4" descr="figure_11.png"/>
+          <p:cNvPr id="5" name="Picture 4" descr="img_05.jpg"/>
           <p:cNvPicPr>
             <a:picLocks noChangeAspect="1"/>
           </p:cNvPicPr>
@@ -5287,8 +5438,8 @@
         </p:blipFill>
         <p:spPr>
           <a:xfrm>
-            <a:off x="6675120" y="1898294"/>
-            <a:ext cx="4937760" cy="3061411"/>
+            <a:off x="6675120" y="2019974"/>
+            <a:ext cx="4937760" cy="2818050"/>
           </a:xfrm>
           <a:prstGeom prst="rect">
             <a:avLst/>
@@ -5326,7 +5477,7 @@
               </a:defRPr>
             </a:pPr>
             <a:r>
-              <a:t>12 / 15</a:t>
+              <a:t>12 / 16</a:t>
             </a:r>
           </a:p>
         </p:txBody>
@@ -5432,69 +5583,14 @@
               </a:defRPr>
             </a:pPr>
             <a:r>
-              <a:t>Station 4 — Outputs</a:t>
-            </a:r>
-          </a:p>
-        </p:txBody>
-      </p:sp>
-      <p:sp>
-        <p:nvSpPr>
-          <p:cNvPr id="4" name="TextBox 3"/>
-          <p:cNvSpPr txBox="1"/>
-          <p:nvPr/>
-        </p:nvSpPr>
-        <p:spPr>
-          <a:xfrm>
-            <a:off x="822960" y="1737360"/>
-            <a:ext cx="5577840" cy="4572000"/>
-          </a:xfrm>
-          <a:prstGeom prst="rect">
-            <a:avLst/>
-          </a:prstGeom>
-          <a:noFill/>
-        </p:spPr>
-        <p:txBody>
-          <a:bodyPr wrap="square">
-            <a:spAutoFit/>
-          </a:bodyPr>
-          <a:lstStyle/>
-          <a:p>
-            <a:pPr>
-              <a:spcAft>
-                <a:spcPts val="1200"/>
-              </a:spcAft>
-              <a:defRPr sz="1800">
-                <a:solidFill>
-                  <a:srgbClr val="F2F0EB"/>
-                </a:solidFill>
-                <a:latin typeface="Helvetica Neue"/>
-              </a:defRPr>
-            </a:pPr>
-            <a:r>
-              <a:t>•  Five finished files, each on its own card</a:t>
-            </a:r>
-          </a:p>
-          <a:p>
-            <a:pPr>
-              <a:spcAft>
-                <a:spcPts val="1200"/>
-              </a:spcAft>
-              <a:defRPr sz="1800">
-                <a:solidFill>
-                  <a:srgbClr val="F2F0EB"/>
-                </a:solidFill>
-                <a:latin typeface="Helvetica Neue"/>
-              </a:defRPr>
-            </a:pPr>
-            <a:r>
-              <a:t>•  ~40¢ per full production; quick reruns ~1/10 cost</a:t>
+              <a:t>How you fix the voice</a:t>
             </a:r>
           </a:p>
         </p:txBody>
       </p:sp>
       <p:pic>
         <p:nvPicPr>
-          <p:cNvPr id="5" name="Picture 4" descr="img_06.jpg"/>
+          <p:cNvPr id="4" name="Picture 3" descr="figure_12.png"/>
           <p:cNvPicPr>
             <a:picLocks noChangeAspect="1"/>
           </p:cNvPicPr>
@@ -5508,8 +5604,8 @@
         </p:blipFill>
         <p:spPr>
           <a:xfrm>
-            <a:off x="6675120" y="2019974"/>
-            <a:ext cx="4937760" cy="2818050"/>
+            <a:off x="6675120" y="1898294"/>
+            <a:ext cx="4937760" cy="3061411"/>
           </a:xfrm>
           <a:prstGeom prst="rect">
             <a:avLst/>
@@ -5518,7 +5614,7 @@
       </p:pic>
       <p:sp>
         <p:nvSpPr>
-          <p:cNvPr id="6" name="TextBox 5"/>
+          <p:cNvPr id="5" name="TextBox 4"/>
           <p:cNvSpPr txBox="1"/>
           <p:nvPr/>
         </p:nvSpPr>
@@ -5547,7 +5643,7 @@
               </a:defRPr>
             </a:pPr>
             <a:r>
-              <a:t>13 / 15</a:t>
+              <a:t>13 / 16</a:t>
             </a:r>
           </a:p>
         </p:txBody>
@@ -5653,7 +5749,7 @@
               </a:defRPr>
             </a:pPr>
             <a:r>
-              <a:t>Which output do I need?</a:t>
+              <a:t>Station 4 — the outputs</a:t>
             </a:r>
           </a:p>
         </p:txBody>
@@ -5692,14 +5788,62 @@
               </a:defRPr>
             </a:pPr>
             <a:r>
-              <a:t>•  Render assembles all five from your current work</a:t>
+              <a:t>•  Render Production packages everything</a:t>
+            </a:r>
+          </a:p>
+          <a:p>
+            <a:pPr>
+              <a:spcAft>
+                <a:spcPts val="1200"/>
+              </a:spcAft>
+              <a:defRPr sz="1800">
+                <a:solidFill>
+                  <a:srgbClr val="F2F0EB"/>
+                </a:solidFill>
+                <a:latin typeface="Helvetica Neue"/>
+              </a:defRPr>
+            </a:pPr>
+            <a:r>
+              <a:t>•  Audio, Transcript, Slideshow cards</a:t>
+            </a:r>
+          </a:p>
+          <a:p>
+            <a:pPr>
+              <a:spcAft>
+                <a:spcPts val="1200"/>
+              </a:spcAft>
+              <a:defRPr sz="1800">
+                <a:solidFill>
+                  <a:srgbClr val="F2F0EB"/>
+                </a:solidFill>
+                <a:latin typeface="Helvetica Neue"/>
+              </a:defRPr>
+            </a:pPr>
+            <a:r>
+              <a:t>•  Video preview and PowerPoint download</a:t>
+            </a:r>
+          </a:p>
+          <a:p>
+            <a:pPr>
+              <a:spcAft>
+                <a:spcPts val="1200"/>
+              </a:spcAft>
+              <a:defRPr sz="1800">
+                <a:solidFill>
+                  <a:srgbClr val="F2F0EB"/>
+                </a:solidFill>
+                <a:latin typeface="Helvetica Neue"/>
+              </a:defRPr>
+            </a:pPr>
+            <a:r>
+              <a:t>•  YouTube: publish private in one click</a:t>
             </a:r>
           </a:p>
         </p:txBody>
       </p:sp>
       <p:pic>
         <p:nvPicPr>
-          <p:cNvPr id="5" name="Picture 4" descr="figure_13.png"/>
+          <p:cNvPr id="5" name="Picture 4" descr="img_06.jpg"/>
           <p:cNvPicPr>
             <a:picLocks noChangeAspect="1"/>
           </p:cNvPicPr>
@@ -5713,8 +5857,8 @@
         </p:blipFill>
         <p:spPr>
           <a:xfrm>
-            <a:off x="6675120" y="1898294"/>
-            <a:ext cx="4937760" cy="3061411"/>
+            <a:off x="6675120" y="2079933"/>
+            <a:ext cx="4937760" cy="2698133"/>
           </a:xfrm>
           <a:prstGeom prst="rect">
             <a:avLst/>
@@ -5752,7 +5896,7 @@
               </a:defRPr>
             </a:pPr>
             <a:r>
-              <a:t>14 / 15</a:t>
+              <a:t>14 / 16</a:t>
             </a:r>
           </a:p>
         </p:txBody>
@@ -5836,7 +5980,7 @@
         <p:spPr>
           <a:xfrm>
             <a:off x="822960" y="457200"/>
-            <a:ext cx="10424160" cy="1371600"/>
+            <a:ext cx="5577840" cy="1371600"/>
           </a:xfrm>
           <a:prstGeom prst="rect">
             <a:avLst/>
@@ -5858,21 +6002,45 @@
               </a:defRPr>
             </a:pPr>
             <a:r>
-              <a:t>Your turn</a:t>
-            </a:r>
-          </a:p>
-        </p:txBody>
-      </p:sp>
-      <p:sp>
-        <p:nvSpPr>
-          <p:cNvPr id="4" name="TextBox 3"/>
+              <a:t>An honest note on cost</a:t>
+            </a:r>
+          </a:p>
+        </p:txBody>
+      </p:sp>
+      <p:pic>
+        <p:nvPicPr>
+          <p:cNvPr id="4" name="Picture 3" descr="figure_14.png"/>
+          <p:cNvPicPr>
+            <a:picLocks noChangeAspect="1"/>
+          </p:cNvPicPr>
+          <p:nvPr/>
+        </p:nvPicPr>
+        <p:blipFill>
+          <a:blip r:embed="rId2"/>
+          <a:stretch>
+            <a:fillRect/>
+          </a:stretch>
+        </p:blipFill>
+        <p:spPr>
+          <a:xfrm>
+            <a:off x="6675120" y="1898294"/>
+            <a:ext cx="4937760" cy="3061411"/>
+          </a:xfrm>
+          <a:prstGeom prst="rect">
+            <a:avLst/>
+          </a:prstGeom>
+        </p:spPr>
+      </p:pic>
+      <p:sp>
+        <p:nvSpPr>
+          <p:cNvPr id="5" name="TextBox 4"/>
           <p:cNvSpPr txBox="1"/>
           <p:nvPr/>
         </p:nvSpPr>
         <p:spPr>
           <a:xfrm>
-            <a:off x="822960" y="1737360"/>
-            <a:ext cx="10424160" cy="1645920"/>
+            <a:off x="10820095" y="6355080"/>
+            <a:ext cx="1005840" cy="365760"/>
           </a:xfrm>
           <a:prstGeom prst="rect">
             <a:avLst/>
@@ -5880,13 +6048,13 @@
           <a:noFill/>
         </p:spPr>
         <p:txBody>
-          <a:bodyPr wrap="square">
+          <a:bodyPr wrap="none">
             <a:spAutoFit/>
           </a:bodyPr>
           <a:lstStyle/>
           <a:p>
-            <a:pPr>
-              <a:defRPr sz="2000" i="1">
+            <a:pPr algn="r">
+              <a:defRPr sz="1200">
                 <a:solidFill>
                   <a:srgbClr val="9AA0AB"/>
                 </a:solidFill>
@@ -5894,21 +6062,91 @@
               </a:defRPr>
             </a:pPr>
             <a:r>
-              <a:t>One pasted link, and you're a producer.</a:t>
-            </a:r>
-          </a:p>
-        </p:txBody>
-      </p:sp>
-      <p:sp>
-        <p:nvSpPr>
-          <p:cNvPr id="5" name="TextBox 4"/>
+              <a:t>15 / 16</a:t>
+            </a:r>
+          </a:p>
+        </p:txBody>
+      </p:sp>
+    </p:spTree>
+  </p:cSld>
+  <p:clrMapOvr>
+    <a:masterClrMapping/>
+  </p:clrMapOvr>
+</p:sld>
+</file>
+
+<file path=ppt/slides/slide16.xml><?xml version="1.0" encoding="utf-8"?>
+<p:sld xmlns:a="http://schemas.openxmlformats.org/drawingml/2006/main" xmlns:p="http://schemas.openxmlformats.org/presentationml/2006/main" xmlns:r="http://schemas.openxmlformats.org/officeDocument/2006/relationships">
+  <p:cSld>
+    <p:bg>
+      <p:bgPr>
+        <a:solidFill>
+          <a:srgbClr val="1E222A"/>
+        </a:solidFill>
+        <a:effectLst/>
+      </p:bgPr>
+    </p:bg>
+    <p:spTree>
+      <p:nvGrpSpPr>
+        <p:cNvPr id="1" name=""/>
+        <p:cNvGrpSpPr/>
+        <p:nvPr/>
+      </p:nvGrpSpPr>
+      <p:grpSpPr/>
+      <p:sp>
+        <p:nvSpPr>
+          <p:cNvPr id="2" name="Rectangle 1"/>
+          <p:cNvSpPr/>
+          <p:nvPr/>
+        </p:nvSpPr>
+        <p:spPr>
+          <a:xfrm>
+            <a:off x="0" y="0"/>
+            <a:ext cx="91440" cy="6858000"/>
+          </a:xfrm>
+          <a:prstGeom prst="rect">
+            <a:avLst/>
+          </a:prstGeom>
+          <a:solidFill>
+            <a:srgbClr val="E8A13C"/>
+          </a:solidFill>
+          <a:ln>
+            <a:noFill/>
+          </a:ln>
+          <a:effectLst/>
+        </p:spPr>
+        <p:style>
+          <a:lnRef idx="1">
+            <a:schemeClr val="accent1"/>
+          </a:lnRef>
+          <a:fillRef idx="3">
+            <a:schemeClr val="accent1"/>
+          </a:fillRef>
+          <a:effectRef idx="2">
+            <a:schemeClr val="accent1"/>
+          </a:effectRef>
+          <a:fontRef idx="minor">
+            <a:schemeClr val="lt1"/>
+          </a:fontRef>
+        </p:style>
+        <p:txBody>
+          <a:bodyPr rtlCol="0" anchor="ctr"/>
+          <a:lstStyle/>
+          <a:p>
+            <a:pPr algn="ctr"/>
+          </a:p>
+        </p:txBody>
+      </p:sp>
+      <p:sp>
+        <p:nvSpPr>
+          <p:cNvPr id="3" name="TextBox 2"/>
           <p:cNvSpPr txBox="1"/>
           <p:nvPr/>
         </p:nvSpPr>
         <p:spPr>
           <a:xfrm>
-            <a:off x="10820095" y="6355080"/>
-            <a:ext cx="1005840" cy="365760"/>
+            <a:off x="822960" y="457200"/>
+            <a:ext cx="10424160" cy="1371600"/>
           </a:xfrm>
           <a:prstGeom prst="rect">
             <a:avLst/>
@@ -5916,6 +6154,78 @@
           <a:noFill/>
         </p:spPr>
         <p:txBody>
+          <a:bodyPr wrap="square">
+            <a:spAutoFit/>
+          </a:bodyPr>
+          <a:lstStyle/>
+          <a:p>
+            <a:pPr>
+              <a:defRPr sz="3000" b="1">
+                <a:solidFill>
+                  <a:srgbClr val="F2F0EB"/>
+                </a:solidFill>
+                <a:latin typeface="Helvetica Neue"/>
+              </a:defRPr>
+            </a:pPr>
+            <a:r>
+              <a:t>Your turn</a:t>
+            </a:r>
+          </a:p>
+        </p:txBody>
+      </p:sp>
+      <p:sp>
+        <p:nvSpPr>
+          <p:cNvPr id="4" name="TextBox 3"/>
+          <p:cNvSpPr txBox="1"/>
+          <p:nvPr/>
+        </p:nvSpPr>
+        <p:spPr>
+          <a:xfrm>
+            <a:off x="822960" y="1737360"/>
+            <a:ext cx="10424160" cy="1645920"/>
+          </a:xfrm>
+          <a:prstGeom prst="rect">
+            <a:avLst/>
+          </a:prstGeom>
+          <a:noFill/>
+        </p:spPr>
+        <p:txBody>
+          <a:bodyPr wrap="square">
+            <a:spAutoFit/>
+          </a:bodyPr>
+          <a:lstStyle/>
+          <a:p>
+            <a:pPr>
+              <a:defRPr sz="2000" i="1">
+                <a:solidFill>
+                  <a:srgbClr val="9AA0AB"/>
+                </a:solidFill>
+                <a:latin typeface="Helvetica Neue"/>
+              </a:defRPr>
+            </a:pPr>
+            <a:r>
+              <a:t>One pasted link — and you're a producer.</a:t>
+            </a:r>
+          </a:p>
+        </p:txBody>
+      </p:sp>
+      <p:sp>
+        <p:nvSpPr>
+          <p:cNvPr id="5" name="TextBox 4"/>
+          <p:cNvSpPr txBox="1"/>
+          <p:nvPr/>
+        </p:nvSpPr>
+        <p:spPr>
+          <a:xfrm>
+            <a:off x="10820095" y="6355080"/>
+            <a:ext cx="1005840" cy="365760"/>
+          </a:xfrm>
+          <a:prstGeom prst="rect">
+            <a:avLst/>
+          </a:prstGeom>
+          <a:noFill/>
+        </p:spPr>
+        <p:txBody>
           <a:bodyPr wrap="none">
             <a:spAutoFit/>
           </a:bodyPr>
@@ -5930,7 +6240,7 @@
               </a:defRPr>
             </a:pPr>
             <a:r>
-              <a:t>15 / 15</a:t>
+              <a:t>16 / 16</a:t>
             </a:r>
           </a:p>
         </p:txBody>
@@ -6014,7 +6324,7 @@
         <p:spPr>
           <a:xfrm>
             <a:off x="822960" y="457200"/>
-            <a:ext cx="10424160" cy="1371600"/>
+            <a:ext cx="5577840" cy="1371600"/>
           </a:xfrm>
           <a:prstGeom prst="rect">
             <a:avLst/>
@@ -6036,21 +6346,45 @@
               </a:defRPr>
             </a:pPr>
             <a:r>
-              <a:t>The core idea</a:t>
-            </a:r>
-          </a:p>
-        </p:txBody>
-      </p:sp>
-      <p:sp>
-        <p:nvSpPr>
-          <p:cNvPr id="4" name="TextBox 3"/>
+              <a:t>What the studio makes</a:t>
+            </a:r>
+          </a:p>
+        </p:txBody>
+      </p:sp>
+      <p:pic>
+        <p:nvPicPr>
+          <p:cNvPr id="4" name="Picture 3" descr="figure_01.png"/>
+          <p:cNvPicPr>
+            <a:picLocks noChangeAspect="1"/>
+          </p:cNvPicPr>
+          <p:nvPr/>
+        </p:nvPicPr>
+        <p:blipFill>
+          <a:blip r:embed="rId2"/>
+          <a:stretch>
+            <a:fillRect/>
+          </a:stretch>
+        </p:blipFill>
+        <p:spPr>
+          <a:xfrm>
+            <a:off x="6675120" y="1898294"/>
+            <a:ext cx="4937760" cy="3061411"/>
+          </a:xfrm>
+          <a:prstGeom prst="rect">
+            <a:avLst/>
+          </a:prstGeom>
+        </p:spPr>
+      </p:pic>
+      <p:sp>
+        <p:nvSpPr>
+          <p:cNvPr id="5" name="TextBox 4"/>
           <p:cNvSpPr txBox="1"/>
           <p:nvPr/>
         </p:nvSpPr>
         <p:spPr>
           <a:xfrm>
-            <a:off x="822960" y="1737360"/>
-            <a:ext cx="10424160" cy="1645920"/>
+            <a:off x="10820095" y="6355080"/>
+            <a:ext cx="1005840" cy="365760"/>
           </a:xfrm>
           <a:prstGeom prst="rect">
             <a:avLst/>
@@ -6058,42 +6392,6 @@
           <a:noFill/>
         </p:spPr>
         <p:txBody>
-          <a:bodyPr wrap="square">
-            <a:spAutoFit/>
-          </a:bodyPr>
-          <a:lstStyle/>
-          <a:p>
-            <a:pPr>
-              <a:defRPr sz="2000" i="1">
-                <a:solidFill>
-                  <a:srgbClr val="9AA0AB"/>
-                </a:solidFill>
-                <a:latin typeface="Helvetica Neue"/>
-              </a:defRPr>
-            </a:pPr>
-            <a:r>
-              <a:t>You describe. The studio produces.</a:t>
-            </a:r>
-          </a:p>
-        </p:txBody>
-      </p:sp>
-      <p:sp>
-        <p:nvSpPr>
-          <p:cNvPr id="5" name="TextBox 4"/>
-          <p:cNvSpPr txBox="1"/>
-          <p:nvPr/>
-        </p:nvSpPr>
-        <p:spPr>
-          <a:xfrm>
-            <a:off x="10820095" y="6355080"/>
-            <a:ext cx="1005840" cy="365760"/>
-          </a:xfrm>
-          <a:prstGeom prst="rect">
-            <a:avLst/>
-          </a:prstGeom>
-          <a:noFill/>
-        </p:spPr>
-        <p:txBody>
           <a:bodyPr wrap="none">
             <a:spAutoFit/>
           </a:bodyPr>
@@ -6108,7 +6406,7 @@
               </a:defRPr>
             </a:pPr>
             <a:r>
-              <a:t>2 / 15</a:t>
+              <a:t>2 / 16</a:t>
             </a:r>
           </a:p>
         </p:txBody>
@@ -6192,7 +6490,7 @@
         <p:spPr>
           <a:xfrm>
             <a:off x="822960" y="457200"/>
-            <a:ext cx="5577840" cy="1371600"/>
+            <a:ext cx="10424160" cy="1371600"/>
           </a:xfrm>
           <a:prstGeom prst="rect">
             <a:avLst/>
@@ -6214,7 +6512,7 @@
               </a:defRPr>
             </a:pPr>
             <a:r>
-              <a:t>Your first look</a:t>
+              <a:t>The core idea</a:t>
             </a:r>
           </a:p>
         </p:txBody>
@@ -6228,7 +6526,7 @@
         <p:spPr>
           <a:xfrm>
             <a:off x="822960" y="1737360"/>
-            <a:ext cx="5577840" cy="4572000"/>
+            <a:ext cx="10424160" cy="1645920"/>
           </a:xfrm>
           <a:prstGeom prst="rect">
             <a:avLst/>
@@ -6242,81 +6540,22 @@
           <a:lstStyle/>
           <a:p>
             <a:pPr>
-              <a:spcAft>
-                <a:spcPts val="1200"/>
-              </a:spcAft>
-              <a:defRPr sz="1800">
-                <a:solidFill>
-                  <a:srgbClr val="F2F0EB"/>
+              <a:defRPr sz="2000" i="1">
+                <a:solidFill>
+                  <a:srgbClr val="9AA0AB"/>
                 </a:solidFill>
                 <a:latin typeface="Helvetica Neue"/>
               </a:defRPr>
             </a:pPr>
             <a:r>
-              <a:t>•  Left: library of everything you've made</a:t>
-            </a:r>
-          </a:p>
-          <a:p>
-            <a:pPr>
-              <a:spcAft>
-                <a:spcPts val="1200"/>
-              </a:spcAft>
-              <a:defRPr sz="1800">
-                <a:solidFill>
-                  <a:srgbClr val="F2F0EB"/>
-                </a:solidFill>
-                <a:latin typeface="Helvetica Neue"/>
-              </a:defRPr>
-            </a:pPr>
-            <a:r>
-              <a:t>•  Amber New Generation starts every project</a:t>
-            </a:r>
-          </a:p>
-          <a:p>
-            <a:pPr>
-              <a:spcAft>
-                <a:spcPts val="1200"/>
-              </a:spcAft>
-              <a:defRPr sz="1800">
-                <a:solidFill>
-                  <a:srgbClr val="F2F0EB"/>
-                </a:solidFill>
-                <a:latin typeface="Helvetica Neue"/>
-              </a:defRPr>
-            </a:pPr>
-            <a:r>
-              <a:t>•  Right: workspace — "From source to sound"</a:t>
-            </a:r>
-          </a:p>
-        </p:txBody>
-      </p:sp>
-      <p:pic>
-        <p:nvPicPr>
-          <p:cNvPr id="5" name="Picture 4" descr="img_01.jpg"/>
-          <p:cNvPicPr>
-            <a:picLocks noChangeAspect="1"/>
-          </p:cNvPicPr>
-          <p:nvPr/>
-        </p:nvPicPr>
-        <p:blipFill>
-          <a:blip r:embed="rId2"/>
-          <a:stretch>
-            <a:fillRect/>
-          </a:stretch>
-        </p:blipFill>
-        <p:spPr>
-          <a:xfrm>
-            <a:off x="6675120" y="2019974"/>
-            <a:ext cx="4937760" cy="2818050"/>
-          </a:xfrm>
-          <a:prstGeom prst="rect">
-            <a:avLst/>
-          </a:prstGeom>
-        </p:spPr>
-      </p:pic>
-      <p:sp>
-        <p:nvSpPr>
-          <p:cNvPr id="6" name="TextBox 5"/>
+              <a:t>You describe. The studio produces. You never edit by hand.</a:t>
+            </a:r>
+          </a:p>
+        </p:txBody>
+      </p:sp>
+      <p:sp>
+        <p:nvSpPr>
+          <p:cNvPr id="5" name="TextBox 4"/>
           <p:cNvSpPr txBox="1"/>
           <p:nvPr/>
         </p:nvSpPr>
@@ -6345,7 +6584,7 @@
               </a:defRPr>
             </a:pPr>
             <a:r>
-              <a:t>3 / 15</a:t>
+              <a:t>3 / 16</a:t>
             </a:r>
           </a:p>
         </p:txBody>
@@ -6451,7 +6690,7 @@
               </a:defRPr>
             </a:pPr>
             <a:r>
-              <a:t>Step 1 — the Source box</a:t>
+              <a:t>Your first look</a:t>
             </a:r>
           </a:p>
         </p:txBody>
@@ -6490,7 +6729,7 @@
               </a:defRPr>
             </a:pPr>
             <a:r>
-              <a:t>•  Choose URL or PDF upload</a:t>
+              <a:t>•  Dark page, split in two</a:t>
             </a:r>
           </a:p>
           <a:p>
@@ -6506,7 +6745,7 @@
               </a:defRPr>
             </a:pPr>
             <a:r>
-              <a:t>•  Paste a web address in the field</a:t>
+              <a:t>•  Left: library of all your work</a:t>
             </a:r>
           </a:p>
           <a:p>
@@ -6522,7 +6761,7 @@
               </a:defRPr>
             </a:pPr>
             <a:r>
-              <a:t>•  Or drag a PDF onto the box</a:t>
+              <a:t>•  Search box always on top</a:t>
             </a:r>
           </a:p>
           <a:p>
@@ -6538,7 +6777,23 @@
               </a:defRPr>
             </a:pPr>
             <a:r>
-              <a:t>•  Filename shows in amber when attached</a:t>
+              <a:t>•  Amber New Generation starts projects</a:t>
+            </a:r>
+          </a:p>
+          <a:p>
+            <a:pPr>
+              <a:spcAft>
+                <a:spcPts val="1200"/>
+              </a:spcAft>
+              <a:defRPr sz="1800">
+                <a:solidFill>
+                  <a:srgbClr val="F2F0EB"/>
+                </a:solidFill>
+                <a:latin typeface="Helvetica Neue"/>
+              </a:defRPr>
+            </a:pPr>
+            <a:r>
+              <a:t>•  Right: workspace opens on the form</a:t>
             </a:r>
           </a:p>
         </p:txBody>
@@ -6574,7 +6829,7 @@
               </a:defRPr>
             </a:pPr>
             <a:r>
-              <a:t>4 / 15</a:t>
+              <a:t>4 / 16</a:t>
             </a:r>
           </a:p>
         </p:txBody>
@@ -6658,7 +6913,7 @@
         <p:spPr>
           <a:xfrm>
             <a:off x="822960" y="457200"/>
-            <a:ext cx="10424160" cy="1371600"/>
+            <a:ext cx="5577840" cy="1371600"/>
           </a:xfrm>
           <a:prstGeom prst="rect">
             <a:avLst/>
@@ -6680,7 +6935,7 @@
               </a:defRPr>
             </a:pPr>
             <a:r>
-              <a:t>Step 2 — the three decisions</a:t>
+              <a:t>The form: from source to sound</a:t>
             </a:r>
           </a:p>
         </p:txBody>
@@ -6694,7 +6949,7 @@
         <p:spPr>
           <a:xfrm>
             <a:off x="822960" y="1737360"/>
-            <a:ext cx="10424160" cy="4572000"/>
+            <a:ext cx="5577840" cy="4572000"/>
           </a:xfrm>
           <a:prstGeom prst="rect">
             <a:avLst/>
@@ -6719,7 +6974,7 @@
               </a:defRPr>
             </a:pPr>
             <a:r>
-              <a:t>•  Mode: Podcast, Summary, or Readout</a:t>
+              <a:t>•  Box one is Source</a:t>
             </a:r>
           </a:p>
           <a:p>
@@ -6735,7 +6990,7 @@
               </a:defRPr>
             </a:pPr>
             <a:r>
-              <a:t>•  Run Until: Script Draft (cheap start) or Full</a:t>
+              <a:t>•  Paste a URL, or upload a PDF</a:t>
             </a:r>
           </a:p>
           <a:p>
@@ -6751,30 +7006,38 @@
               </a:defRPr>
             </a:pPr>
             <a:r>
-              <a:t>•  Audience: describe who's listening</a:t>
-            </a:r>
-          </a:p>
-          <a:p>
-            <a:pPr>
-              <a:spcAft>
-                <a:spcPts val="1200"/>
-              </a:spcAft>
-              <a:defRPr sz="1800">
-                <a:solidFill>
-                  <a:srgbClr val="F2F0EB"/>
-                </a:solidFill>
-                <a:latin typeface="Helvetica Neue"/>
-              </a:defRPr>
-            </a:pPr>
-            <a:r>
-              <a:t>•  Personality &amp; voices — optional</a:t>
-            </a:r>
-          </a:p>
-        </p:txBody>
-      </p:sp>
-      <p:sp>
-        <p:nvSpPr>
-          <p:cNvPr id="5" name="TextBox 4"/>
+              <a:t>•  Or drag a PDF onto the box</a:t>
+            </a:r>
+          </a:p>
+        </p:txBody>
+      </p:sp>
+      <p:pic>
+        <p:nvPicPr>
+          <p:cNvPr id="5" name="Picture 4" descr="img_01.jpg"/>
+          <p:cNvPicPr>
+            <a:picLocks noChangeAspect="1"/>
+          </p:cNvPicPr>
+          <p:nvPr/>
+        </p:nvPicPr>
+        <p:blipFill>
+          <a:blip r:embed="rId2"/>
+          <a:stretch>
+            <a:fillRect/>
+          </a:stretch>
+        </p:blipFill>
+        <p:spPr>
+          <a:xfrm>
+            <a:off x="6675120" y="2019974"/>
+            <a:ext cx="4937760" cy="2818050"/>
+          </a:xfrm>
+          <a:prstGeom prst="rect">
+            <a:avLst/>
+          </a:prstGeom>
+        </p:spPr>
+      </p:pic>
+      <p:sp>
+        <p:nvSpPr>
+          <p:cNvPr id="6" name="TextBox 5"/>
           <p:cNvSpPr txBox="1"/>
           <p:nvPr/>
         </p:nvSpPr>
@@ -6803,7 +7066,7 @@
               </a:defRPr>
             </a:pPr>
             <a:r>
-              <a:t>5 / 15</a:t>
+              <a:t>5 / 16</a:t>
             </a:r>
           </a:p>
         </p:txBody>
@@ -6909,7 +7172,7 @@
               </a:defRPr>
             </a:pPr>
             <a:r>
-              <a:t>Step 3 — Slides &amp; Captions</a:t>
+              <a:t>The three decisions that matter</a:t>
             </a:r>
           </a:p>
         </p:txBody>
@@ -6948,7 +7211,7 @@
               </a:defRPr>
             </a:pPr>
             <a:r>
-              <a:t>•  Slides: web, video, PowerPoint, or combo</a:t>
+              <a:t>•  Mode: Podcast, Summary, or Readout</a:t>
             </a:r>
           </a:p>
           <a:p>
@@ -6964,7 +7227,7 @@
               </a:defRPr>
             </a:pPr>
             <a:r>
-              <a:t>•  Captions: Burned in, or Toggle on/off</a:t>
+              <a:t>•  Run Until: Script Draft (cheap start) or Full</a:t>
             </a:r>
           </a:p>
           <a:p>
@@ -6980,7 +7243,7 @@
               </a:defRPr>
             </a:pPr>
             <a:r>
-              <a:t>•  Animations glide content in element by element</a:t>
+              <a:t>•  Audience: describe who's listening</a:t>
             </a:r>
           </a:p>
           <a:p>
@@ -6996,7 +7259,7 @@
               </a:defRPr>
             </a:pPr>
             <a:r>
-              <a:t>•  Amber Start Generation begins it all</a:t>
+              <a:t>•  Personality &amp; voices are optional</a:t>
             </a:r>
           </a:p>
         </p:txBody>
@@ -7032,7 +7295,7 @@
               </a:defRPr>
             </a:pPr>
             <a:r>
-              <a:t>6 / 15</a:t>
+              <a:t>6 / 16</a:t>
             </a:r>
           </a:p>
         </p:txBody>
@@ -7116,7 +7379,7 @@
         <p:spPr>
           <a:xfrm>
             <a:off x="822960" y="457200"/>
-            <a:ext cx="5577840" cy="1371600"/>
+            <a:ext cx="10424160" cy="1371600"/>
           </a:xfrm>
           <a:prstGeom prst="rect">
             <a:avLst/>
@@ -7138,7 +7401,7 @@
               </a:defRPr>
             </a:pPr>
             <a:r>
-              <a:t>The four stations</a:t>
+              <a:t>Slides and captions</a:t>
             </a:r>
           </a:p>
         </p:txBody>
@@ -7152,7 +7415,7 @@
         <p:spPr>
           <a:xfrm>
             <a:off x="822960" y="1737360"/>
-            <a:ext cx="5577840" cy="4572000"/>
+            <a:ext cx="10424160" cy="4572000"/>
           </a:xfrm>
           <a:prstGeom prst="rect">
             <a:avLst/>
@@ -7177,38 +7440,62 @@
               </a:defRPr>
             </a:pPr>
             <a:r>
-              <a:t>•  Stop anywhere; later stations update automatically</a:t>
-            </a:r>
-          </a:p>
-        </p:txBody>
-      </p:sp>
-      <p:pic>
-        <p:nvPicPr>
-          <p:cNvPr id="5" name="Picture 4" descr="figure_06.png"/>
-          <p:cNvPicPr>
-            <a:picLocks noChangeAspect="1"/>
-          </p:cNvPicPr>
-          <p:nvPr/>
-        </p:nvPicPr>
-        <p:blipFill>
-          <a:blip r:embed="rId2"/>
-          <a:stretch>
-            <a:fillRect/>
-          </a:stretch>
-        </p:blipFill>
-        <p:spPr>
-          <a:xfrm>
-            <a:off x="6675120" y="1898294"/>
-            <a:ext cx="4937760" cy="3061411"/>
-          </a:xfrm>
-          <a:prstGeom prst="rect">
-            <a:avLst/>
-          </a:prstGeom>
-        </p:spPr>
-      </p:pic>
-      <p:sp>
-        <p:nvSpPr>
-          <p:cNvPr id="6" name="TextBox 5"/>
+              <a:t>•  Slides: web, video, PowerPoint, or mix</a:t>
+            </a:r>
+          </a:p>
+          <a:p>
+            <a:pPr>
+              <a:spcAft>
+                <a:spcPts val="1200"/>
+              </a:spcAft>
+              <a:defRPr sz="1800">
+                <a:solidFill>
+                  <a:srgbClr val="F2F0EB"/>
+                </a:solidFill>
+                <a:latin typeface="Helvetica Neue"/>
+              </a:defRPr>
+            </a:pPr>
+            <a:r>
+              <a:t>•  Captions: Burned in, or Toggle on/off</a:t>
+            </a:r>
+          </a:p>
+          <a:p>
+            <a:pPr>
+              <a:spcAft>
+                <a:spcPts val="1200"/>
+              </a:spcAft>
+              <a:defRPr sz="1800">
+                <a:solidFill>
+                  <a:srgbClr val="F2F0EB"/>
+                </a:solidFill>
+                <a:latin typeface="Helvetica Neue"/>
+              </a:defRPr>
+            </a:pPr>
+            <a:r>
+              <a:t>•  Animations: content glides in piece by piece</a:t>
+            </a:r>
+          </a:p>
+          <a:p>
+            <a:pPr>
+              <a:spcAft>
+                <a:spcPts val="1200"/>
+              </a:spcAft>
+              <a:defRPr sz="1800">
+                <a:solidFill>
+                  <a:srgbClr val="F2F0EB"/>
+                </a:solidFill>
+                <a:latin typeface="Helvetica Neue"/>
+              </a:defRPr>
+            </a:pPr>
+            <a:r>
+              <a:t>•  Then press Start Generation</a:t>
+            </a:r>
+          </a:p>
+        </p:txBody>
+      </p:sp>
+      <p:sp>
+        <p:nvSpPr>
+          <p:cNvPr id="5" name="TextBox 4"/>
           <p:cNvSpPr txBox="1"/>
           <p:nvPr/>
         </p:nvSpPr>
@@ -7237,7 +7524,7 @@
               </a:defRPr>
             </a:pPr>
             <a:r>
-              <a:t>7 / 15</a:t>
+              <a:t>7 / 16</a:t>
             </a:r>
           </a:p>
         </p:txBody>
@@ -7343,69 +7630,14 @@
               </a:defRPr>
             </a:pPr>
             <a:r>
-              <a:t>Station 1 — Script</a:t>
-            </a:r>
-          </a:p>
-        </p:txBody>
-      </p:sp>
-      <p:sp>
-        <p:nvSpPr>
-          <p:cNvPr id="4" name="TextBox 3"/>
-          <p:cNvSpPr txBox="1"/>
-          <p:nvPr/>
-        </p:nvSpPr>
-        <p:spPr>
-          <a:xfrm>
-            <a:off x="822960" y="1737360"/>
-            <a:ext cx="5577840" cy="4572000"/>
-          </a:xfrm>
-          <a:prstGeom prst="rect">
-            <a:avLst/>
-          </a:prstGeom>
-          <a:noFill/>
-        </p:spPr>
-        <p:txBody>
-          <a:bodyPr wrap="square">
-            <a:spAutoFit/>
-          </a:bodyPr>
-          <a:lstStyle/>
-          <a:p>
-            <a:pPr>
-              <a:spcAft>
-                <a:spcPts val="1200"/>
-              </a:spcAft>
-              <a:defRPr sz="1800">
-                <a:solidFill>
-                  <a:srgbClr val="F2F0EB"/>
-                </a:solidFill>
-                <a:latin typeface="Helvetica Neue"/>
-              </a:defRPr>
-            </a:pPr>
-            <a:r>
-              <a:t>•  Every spoken line, numbered, with speaker badges</a:t>
-            </a:r>
-          </a:p>
-          <a:p>
-            <a:pPr>
-              <a:spcAft>
-                <a:spcPts val="1200"/>
-              </a:spcAft>
-              <a:defRPr sz="1800">
-                <a:solidFill>
-                  <a:srgbClr val="F2F0EB"/>
-                </a:solidFill>
-                <a:latin typeface="Helvetica Neue"/>
-              </a:defRPr>
-            </a:pPr>
-            <a:r>
-              <a:t>•  Revise in plain words; other lines stay untouched</a:t>
+              <a:t>The four stations</a:t>
             </a:r>
           </a:p>
         </p:txBody>
       </p:sp>
       <p:pic>
         <p:nvPicPr>
-          <p:cNvPr id="5" name="Picture 4" descr="img_02.jpg"/>
+          <p:cNvPr id="4" name="Picture 3" descr="figure_07.png"/>
           <p:cNvPicPr>
             <a:picLocks noChangeAspect="1"/>
           </p:cNvPicPr>
@@ -7419,8 +7651,8 @@
         </p:blipFill>
         <p:spPr>
           <a:xfrm>
-            <a:off x="6675120" y="2019974"/>
-            <a:ext cx="4937760" cy="2818050"/>
+            <a:off x="6675120" y="1898294"/>
+            <a:ext cx="4937760" cy="3061411"/>
           </a:xfrm>
           <a:prstGeom prst="rect">
             <a:avLst/>
@@ -7429,7 +7661,7 @@
       </p:pic>
       <p:sp>
         <p:nvSpPr>
-          <p:cNvPr id="6" name="TextBox 5"/>
+          <p:cNvPr id="5" name="TextBox 4"/>
           <p:cNvSpPr txBox="1"/>
           <p:nvPr/>
         </p:nvSpPr>
@@ -7458,7 +7690,7 @@
               </a:defRPr>
             </a:pPr>
             <a:r>
-              <a:t>8 / 15</a:t>
+              <a:t>8 / 16</a:t>
             </a:r>
           </a:p>
         </p:txBody>
@@ -7564,7 +7796,7 @@
               </a:defRPr>
             </a:pPr>
             <a:r>
-              <a:t>Station 2 — Slides</a:t>
+              <a:t>Station 1 — the script</a:t>
             </a:r>
           </a:p>
         </p:txBody>
@@ -7603,7 +7835,7 @@
               </a:defRPr>
             </a:pPr>
             <a:r>
-              <a:t>•  Storyboard of cards, one per slide</a:t>
+              <a:t>•  Every line the voice will speak</a:t>
             </a:r>
           </a:p>
           <a:p>
@@ -7619,7 +7851,7 @@
               </a:defRPr>
             </a:pPr>
             <a:r>
-              <a:t>•  Real images and auto-drawn charts</a:t>
+              <a:t>•  Revise in plain words at the bottom</a:t>
             </a:r>
           </a:p>
           <a:p>
@@ -7635,14 +7867,30 @@
               </a:defRPr>
             </a:pPr>
             <a:r>
-              <a:t>•  Asset Inventory lists every visual</a:t>
+              <a:t>•  Only the lines you name change</a:t>
+            </a:r>
+          </a:p>
+          <a:p>
+            <a:pPr>
+              <a:spcAft>
+                <a:spcPts val="1200"/>
+              </a:spcAft>
+              <a:defRPr sz="1800">
+                <a:solidFill>
+                  <a:srgbClr val="F2F0EB"/>
+                </a:solidFill>
+                <a:latin typeface="Helvetica Neue"/>
+              </a:defRPr>
+            </a:pPr>
+            <a:r>
+              <a:t>•  Polish while words are cheap</a:t>
             </a:r>
           </a:p>
         </p:txBody>
       </p:sp>
       <p:pic>
         <p:nvPicPr>
-          <p:cNvPr id="5" name="Picture 4" descr="img_03.jpg"/>
+          <p:cNvPr id="5" name="Picture 4" descr="img_02.jpg"/>
           <p:cNvPicPr>
             <a:picLocks noChangeAspect="1"/>
           </p:cNvPicPr>
@@ -7695,7 +7943,7 @@
               </a:defRPr>
             </a:pPr>
             <a:r>
-              <a:t>9 / 15</a:t>
+              <a:t>9 / 16</a:t>
             </a:r>
           </a:p>
         </p:txBody>

</xml_diff>